<commit_message>
Dedupe account-lockout bug (12-18 -> single #12); 17 bugs -> 12
Bugs 12,14-18 were identical except Role (now dropped per PDF spec).
Merged into one defect (all roles noted). Updated deck, README counts:
severity 8 low/4 medium, priority 3 high/5 medium/4 low.
</commit_message>
<xml_diff>
--- a/SauceDemo_Test_Report.pptx
+++ b/SauceDemo_Test_Report.pptx
@@ -3356,7 +3356,7 @@
                 </a:solidFill>
                 <a:latin typeface="Calibri"/>
               </a:rPr>
-              <a:t>99 Test Case  •  82 PASS / 17 FAIL  •  17 Bug Dilaporkan</a:t>
+              <a:t>99 Test Case  •  82 PASS / 17 FAIL  •  12 Bug Dilaporkan</a:t>
             </a:r>
           </a:p>
           <a:p>
@@ -6050,7 +6050,7 @@
                 </a:solidFill>
                 <a:latin typeface="Calibri"/>
               </a:rPr>
-              <a:t>2.  Perbaiki celah keamanan account-lockout (Bug #12-18).</a:t>
+              <a:t>2.  Perbaiki celah keamanan account-lockout (Bug #12).</a:t>
             </a:r>
           </a:p>
           <a:p>
@@ -6404,7 +6404,7 @@
                 </a:solidFill>
                 <a:latin typeface="Calibri"/>
               </a:rPr>
-              <a:t>99 Test Case  •  82 PASS / 17 FAIL  •  17 Bug  •  Keputusan: Conditional GO</a:t>
+              <a:t>99 Test Case  •  82 PASS / 17 FAIL  •  12 Bug  •  Keputusan: Conditional GO</a:t>
             </a:r>
           </a:p>
         </p:txBody>
@@ -7591,7 +7591,7 @@
                 </a:solidFill>
                 <a:latin typeface="Calibri"/>
               </a:rPr>
-              <a:t>17 bug — severity &amp; priority</a:t>
+              <a:t>12 bug — severity &amp; priority</a:t>
             </a:r>
           </a:p>
         </p:txBody>
@@ -13268,7 +13268,7 @@
                 </a:solidFill>
                 <a:latin typeface="Calibri"/>
               </a:rPr>
-              <a:t>17 bug dilaporkan</a:t>
+              <a:t>12 bug dilaporkan</a:t>
             </a:r>
           </a:p>
         </p:txBody>
@@ -18268,7 +18268,7 @@
                 </a:solidFill>
                 <a:latin typeface="Calibri"/>
               </a:rPr>
-              <a:t>17</a:t>
+              <a:t>12</a:t>
             </a:r>
           </a:p>
         </p:txBody>
@@ -19486,7 +19486,7 @@
                 </a:solidFill>
                 <a:latin typeface="Calibri"/>
               </a:rPr>
-              <a:t>17 bug • SauceDemo (Bug Report).xlsx</a:t>
+              <a:t>12 bug • SauceDemo (Bug Report).xlsx</a:t>
             </a:r>
           </a:p>
         </p:txBody>
@@ -19572,7 +19572,7 @@
                 </a:solidFill>
                 <a:latin typeface="Calibri"/>
               </a:rPr>
-              <a:t>17</a:t>
+              <a:t>12</a:t>
             </a:r>
           </a:p>
         </p:txBody>
@@ -19700,7 +19700,7 @@
                 </a:solidFill>
                 <a:latin typeface="Calibri"/>
               </a:rPr>
-              <a:t>17</a:t>
+              <a:t>12</a:t>
             </a:r>
           </a:p>
         </p:txBody>
@@ -20464,7 +20464,7 @@
                 </a:solidFill>
                 <a:latin typeface="Calibri"/>
               </a:rPr>
-              <a:t>13</a:t>
+              <a:t>8</a:t>
             </a:r>
           </a:p>
         </p:txBody>
@@ -20930,7 +20930,7 @@
                 </a:solidFill>
                 <a:latin typeface="Calibri"/>
               </a:rPr>
-              <a:t>10</a:t>
+              <a:t>5</a:t>
             </a:r>
           </a:p>
         </p:txBody>
@@ -21087,7 +21087,7 @@
                 </a:solidFill>
                 <a:latin typeface="Calibri"/>
               </a:rPr>
-              <a:t>Tidak ada bug Critical/High-severity. Semua 17 bug masih ber-status Opened. 3 bug Priority-High menyangkut alur transaksi inti (lihat slide berikut).</a:t>
+              <a:t>Tidak ada bug Critical/High-severity. Semua 12 bug masih ber-status Opened. 3 bug Priority-High menyangkut alur transaksi inti (lihat slide berikut).</a:t>
             </a:r>
           </a:p>
         </p:txBody>
@@ -21319,7 +21319,7 @@
                 </a:solidFill>
                 <a:latin typeface="Calibri"/>
               </a:rPr>
-              <a:t>Daftar Bug (17)</a:t>
+              <a:t>Daftar Bug (12)</a:t>
             </a:r>
           </a:p>
         </p:txBody>
@@ -23958,7 +23958,7 @@
                 </a:solidFill>
                 <a:latin typeface="Calibri"/>
               </a:rPr>
-              <a:t>12-18</a:t>
+              <a:t>12</a:t>
             </a:r>
           </a:p>
         </p:txBody>
@@ -24117,7 +24117,7 @@
                 </a:solidFill>
                 <a:latin typeface="Calibri"/>
               </a:rPr>
-              <a:t>Account not locked after failed logins (6 roles)</a:t>
+              <a:t>Account not locked after failed logins (all roles)</a:t>
             </a:r>
           </a:p>
         </p:txBody>

</xml_diff>

<commit_message>
Dedupe account-lockout test cases (026-031 -> TC-LP-026); 17 fail -> 12
Per-role lockout cases identical after Role column dropped; merged to one.
Totals now 94 cases / 82 PASS / 12 FAIL (87.2%), 1:1 with 12 bugs.
Updated xlsx, deck, README.
</commit_message>
<xml_diff>
--- a/SauceDemo_Test_Report.pptx
+++ b/SauceDemo_Test_Report.pptx
@@ -3356,7 +3356,7 @@
                 </a:solidFill>
                 <a:latin typeface="Calibri"/>
               </a:rPr>
-              <a:t>99 Test Case  •  82 PASS / 17 FAIL  •  12 Bug Dilaporkan</a:t>
+              <a:t>94 Test Case  •  82 PASS / 12 FAIL  •  12 Bug Dilaporkan</a:t>
             </a:r>
           </a:p>
           <a:p>
@@ -6012,7 +6012,7 @@
                 </a:solidFill>
                 <a:latin typeface="Calibri"/>
               </a:rPr>
-              <a:t>Pass rate 82.8% &amp; tanpa bug Critical — layak rilis SETELAH syarat berikut:</a:t>
+              <a:t>Pass rate 87.2% &amp; tanpa bug Critical — layak rilis SETELAH syarat berikut:</a:t>
             </a:r>
           </a:p>
           <a:p>
@@ -6404,7 +6404,7 @@
                 </a:solidFill>
                 <a:latin typeface="Calibri"/>
               </a:rPr>
-              <a:t>99 Test Case  •  82 PASS / 17 FAIL  •  12 Bug  •  Keputusan: Conditional GO</a:t>
+              <a:t>94 Test Case  •  82 PASS / 12 FAIL  •  12 Bug  •  Keputusan: Conditional GO</a:t>
             </a:r>
           </a:p>
         </p:txBody>
@@ -7209,7 +7209,7 @@
                 </a:solidFill>
                 <a:latin typeface="Calibri"/>
               </a:rPr>
-              <a:t>99 case — rekap per modul</a:t>
+              <a:t>94 case — rekap per modul</a:t>
             </a:r>
           </a:p>
         </p:txBody>
@@ -11413,7 +11413,7 @@
                 </a:solidFill>
                 <a:latin typeface="Calibri"/>
               </a:rPr>
-              <a:t>99 test case • SauceDemo (Test Cases).xlsx</a:t>
+              <a:t>94 test case • SauceDemo (Test Cases).xlsx</a:t>
             </a:r>
           </a:p>
         </p:txBody>
@@ -11784,7 +11784,7 @@
                 </a:solidFill>
                 <a:latin typeface="Calibri"/>
               </a:rPr>
-              <a:t>44</a:t>
+              <a:t>39</a:t>
             </a:r>
           </a:p>
         </p:txBody>
@@ -11890,7 +11890,7 @@
                 </a:solidFill>
                 <a:latin typeface="Calibri"/>
               </a:rPr>
-              <a:t>6</a:t>
+              <a:t>1</a:t>
             </a:r>
           </a:p>
         </p:txBody>
@@ -11943,7 +11943,7 @@
                 </a:solidFill>
                 <a:latin typeface="Calibri"/>
               </a:rPr>
-              <a:t>TC-LP-026 … 031 (account lockout)</a:t>
+              <a:t>TC-LP-026 (account lockout, semua role)</a:t>
             </a:r>
           </a:p>
         </p:txBody>
@@ -13109,7 +13109,7 @@
                 </a:solidFill>
                 <a:latin typeface="Calibri"/>
               </a:rPr>
-              <a:t>99</a:t>
+              <a:t>94</a:t>
             </a:r>
           </a:p>
         </p:txBody>
@@ -13215,7 +13215,7 @@
                 </a:solidFill>
                 <a:latin typeface="Calibri"/>
               </a:rPr>
-              <a:t>17</a:t>
+              <a:t>12</a:t>
             </a:r>
           </a:p>
         </p:txBody>
@@ -13319,7 +13319,7 @@
                 </a:solidFill>
                 <a:latin typeface="Calibri"/>
               </a:rPr>
-              <a:t>82.8%  (82 / 99)</a:t>
+              <a:t>87.2%  (82 / 94)</a:t>
             </a:r>
           </a:p>
         </p:txBody>
@@ -13370,7 +13370,7 @@
                 </a:solidFill>
                 <a:latin typeface="Calibri"/>
               </a:rPr>
-              <a:t>Modul Login mendominasi jumlah case (44) karena diuji untuk 6 role. Kegagalan terbesar di Checkout (5) dan Login (6 — semua terkait fitur account-lockout yang tidak ada.)</a:t>
+              <a:t>Modul Login diuji untuk 6 role (39 case). Kegagalan terbesar di Checkout (5); test account-lockout digabung jadi 1 (TC-LP-026) karena identik antar-role.</a:t>
             </a:r>
           </a:p>
         </p:txBody>
@@ -17396,7 +17396,7 @@
                 </a:solidFill>
                 <a:latin typeface="Calibri"/>
               </a:rPr>
-              <a:t>7 PASS (alur inti) + 6 FAIL (bug Priority-High &amp; keamanan) — dipilih dari 99 case.</a:t>
+              <a:t>7 PASS (alur inti) + 6 FAIL (bug Priority-High &amp; keamanan) — dipilih dari 94 case.</a:t>
             </a:r>
           </a:p>
         </p:txBody>
@@ -17756,7 +17756,7 @@
                 </a:solidFill>
                 <a:latin typeface="Calibri"/>
               </a:rPr>
-              <a:t>99</a:t>
+              <a:t>94</a:t>
             </a:r>
           </a:p>
         </p:txBody>
@@ -18012,7 +18012,7 @@
                 </a:solidFill>
                 <a:latin typeface="Calibri"/>
               </a:rPr>
-              <a:t>17</a:t>
+              <a:t>12</a:t>
             </a:r>
           </a:p>
         </p:txBody>
@@ -18140,7 +18140,7 @@
                 </a:solidFill>
                 <a:latin typeface="Calibri"/>
               </a:rPr>
-              <a:t>82.8%</a:t>
+              <a:t>87.2%</a:t>
             </a:r>
           </a:p>
         </p:txBody>
@@ -18408,7 +18408,7 @@
         <p:spPr>
           <a:xfrm>
             <a:off x="2194560" y="3246120"/>
-            <a:ext cx="4773352" cy="292608"/>
+            <a:ext cx="5027253" cy="292608"/>
           </a:xfrm>
           <a:prstGeom prst="rect">
             <a:avLst/>
@@ -18451,8 +18451,8 @@
         </p:nvSpPr>
         <p:spPr>
           <a:xfrm>
-            <a:off x="6967912" y="3246120"/>
-            <a:ext cx="753688" cy="292608"/>
+            <a:off x="7221813" y="3246120"/>
+            <a:ext cx="132297" cy="292608"/>
           </a:xfrm>
           <a:prstGeom prst="rect">
             <a:avLst/>
@@ -18495,7 +18495,7 @@
         </p:nvSpPr>
         <p:spPr>
           <a:xfrm>
-            <a:off x="7813040" y="3200400"/>
+            <a:off x="7445550" y="3200400"/>
             <a:ext cx="2286000" cy="365760"/>
           </a:xfrm>
           <a:prstGeom prst="rect">
@@ -18524,7 +18524,7 @@
                 </a:solidFill>
                 <a:latin typeface="Calibri"/>
               </a:rPr>
-              <a:t>38 pass / 6 fail</a:t>
+              <a:t>38 pass / 1 fail</a:t>
             </a:r>
           </a:p>
         </p:txBody>
@@ -18580,7 +18580,7 @@
         <p:spPr>
           <a:xfrm>
             <a:off x="2194560" y="3749040"/>
-            <a:ext cx="2386676" cy="292608"/>
+            <a:ext cx="2513626" cy="292608"/>
           </a:xfrm>
           <a:prstGeom prst="rect">
             <a:avLst/>
@@ -18623,8 +18623,8 @@
         </p:nvSpPr>
         <p:spPr>
           <a:xfrm>
-            <a:off x="4581236" y="3749040"/>
-            <a:ext cx="376844" cy="292608"/>
+            <a:off x="4708186" y="3749040"/>
+            <a:ext cx="396889" cy="292608"/>
           </a:xfrm>
           <a:prstGeom prst="rect">
             <a:avLst/>
@@ -18667,7 +18667,7 @@
         </p:nvSpPr>
         <p:spPr>
           <a:xfrm>
-            <a:off x="5049520" y="3703320"/>
+            <a:off x="5196515" y="3703320"/>
             <a:ext cx="2286000" cy="365760"/>
           </a:xfrm>
           <a:prstGeom prst="rect">
@@ -18752,7 +18752,7 @@
         <p:spPr>
           <a:xfrm>
             <a:off x="2194560" y="4251960"/>
-            <a:ext cx="1256145" cy="292608"/>
+            <a:ext cx="1322961" cy="292608"/>
           </a:xfrm>
           <a:prstGeom prst="rect">
             <a:avLst/>
@@ -18795,8 +18795,8 @@
         </p:nvSpPr>
         <p:spPr>
           <a:xfrm>
-            <a:off x="3450705" y="4251960"/>
-            <a:ext cx="251229" cy="292608"/>
+            <a:off x="3517521" y="4251960"/>
+            <a:ext cx="264593" cy="292608"/>
           </a:xfrm>
           <a:prstGeom prst="rect">
             <a:avLst/>
@@ -18839,7 +18839,7 @@
         </p:nvSpPr>
         <p:spPr>
           <a:xfrm>
-            <a:off x="3793374" y="4206240"/>
+            <a:off x="3873554" y="4206240"/>
             <a:ext cx="2286000" cy="365760"/>
           </a:xfrm>
           <a:prstGeom prst="rect">
@@ -18924,7 +18924,7 @@
         <p:spPr>
           <a:xfrm>
             <a:off x="2194560" y="4754880"/>
-            <a:ext cx="1256145" cy="292608"/>
+            <a:ext cx="1322961" cy="292608"/>
           </a:xfrm>
           <a:prstGeom prst="rect">
             <a:avLst/>
@@ -18967,8 +18967,8 @@
         </p:nvSpPr>
         <p:spPr>
           <a:xfrm>
-            <a:off x="3450705" y="4754880"/>
-            <a:ext cx="628073" cy="292608"/>
+            <a:off x="3517521" y="4754880"/>
+            <a:ext cx="661481" cy="292608"/>
           </a:xfrm>
           <a:prstGeom prst="rect">
             <a:avLst/>
@@ -19011,7 +19011,7 @@
         </p:nvSpPr>
         <p:spPr>
           <a:xfrm>
-            <a:off x="4170218" y="4709160"/>
+            <a:off x="4270442" y="4709160"/>
             <a:ext cx="2286000" cy="365760"/>
           </a:xfrm>
           <a:prstGeom prst="rect">
@@ -19096,7 +19096,7 @@
         <p:spPr>
           <a:xfrm>
             <a:off x="2194560" y="5257800"/>
-            <a:ext cx="628072" cy="292608"/>
+            <a:ext cx="661480" cy="292608"/>
           </a:xfrm>
           <a:prstGeom prst="rect">
             <a:avLst/>
@@ -19139,8 +19139,8 @@
         </p:nvSpPr>
         <p:spPr>
           <a:xfrm>
-            <a:off x="2822632" y="5257800"/>
-            <a:ext cx="125615" cy="292608"/>
+            <a:off x="2856040" y="5257800"/>
+            <a:ext cx="132297" cy="292608"/>
           </a:xfrm>
           <a:prstGeom prst="rect">
             <a:avLst/>
@@ -19183,7 +19183,7 @@
         </p:nvSpPr>
         <p:spPr>
           <a:xfrm>
-            <a:off x="3039687" y="5212080"/>
+            <a:off x="3079777" y="5212080"/>
             <a:ext cx="2286000" cy="365760"/>
           </a:xfrm>
           <a:prstGeom prst="rect">

</xml_diff>